<commit_message>
:pencil: Small fix lecture 3
</commit_message>
<xml_diff>
--- a/lessons/lesson03_feature_engineering/theory/slides/Lecture3 - Feature Engineering and Biological Representation.pptx
+++ b/lessons/lesson03_feature_engineering/theory/slides/Lecture3 - Feature Engineering and Biological Representation.pptx
@@ -975,6 +975,562 @@
 </c:chartSpace>
 </file>
 
+<file path=ppt/charts/chart3.xml><?xml version="1.0" encoding="utf-8"?>
+<c:chartSpace xmlns:c="http://schemas.openxmlformats.org/drawingml/2006/chart" xmlns:a="http://schemas.openxmlformats.org/drawingml/2006/main" xmlns:r="http://schemas.openxmlformats.org/officeDocument/2006/relationships" xmlns:c16r2="http://schemas.microsoft.com/office/drawing/2015/06/chart">
+  <c:date1904 val="0"/>
+  <c:lang val="en-GB"/>
+  <c:roundedCorners val="1"/>
+  <mc:AlternateContent xmlns:mc="http://schemas.openxmlformats.org/markup-compatibility/2006">
+    <mc:Choice xmlns:c14="http://schemas.microsoft.com/office/drawing/2007/8/2/chart" Requires="c14">
+      <c14:style val="102"/>
+    </mc:Choice>
+    <mc:Fallback>
+      <c:style val="2"/>
+    </mc:Fallback>
+  </mc:AlternateContent>
+  <c:chart>
+    <c:title>
+      <c:tx>
+        <c:rich>
+          <a:bodyPr/>
+          <a:lstStyle/>
+          <a:p>
+            <a:pPr>
+              <a:defRPr sz="1100" b="0" i="0" u="none" strike="noStrike">
+                <a:solidFill>
+                  <a:srgbClr val="12262B"/>
+                </a:solidFill>
+                <a:latin typeface="Arial"/>
+              </a:defRPr>
+            </a:pPr>
+            <a:r>
+              <a:rPr lang="en-GB" sz="1100" b="0" i="0" u="none" strike="noStrike">
+                <a:solidFill>
+                  <a:srgbClr val="12262B"/>
+                </a:solidFill>
+                <a:latin typeface="Arial"/>
+              </a:rPr>
+              <a:t>across patients (ordered by risk)</a:t>
+            </a:r>
+          </a:p>
+        </c:rich>
+      </c:tx>
+      <c:overlay val="0"/>
+    </c:title>
+    <c:autoTitleDeleted val="0"/>
+    <c:plotArea>
+      <c:layout/>
+      <c:lineChart>
+        <c:grouping val="standard"/>
+        <c:varyColors val="0"/>
+        <c:ser>
+          <c:idx val="0"/>
+          <c:order val="0"/>
+          <c:tx>
+            <c:strRef>
+              <c:f>Sheet1!$B$1</c:f>
+              <c:strCache>
+                <c:ptCount val="1"/>
+                <c:pt idx="0">
+                  <c:v>single gene (jittery)</c:v>
+                </c:pt>
+              </c:strCache>
+            </c:strRef>
+          </c:tx>
+          <c:spPr>
+            <a:ln w="25400" cap="flat">
+              <a:solidFill>
+                <a:srgbClr val="C9D7D9"/>
+              </a:solidFill>
+              <a:prstDash val="solid"/>
+              <a:round/>
+            </a:ln>
+            <a:effectLst/>
+          </c:spPr>
+          <c:marker>
+            <c:symbol val="circle"/>
+            <c:size val="6"/>
+            <c:spPr>
+              <a:solidFill>
+                <a:srgbClr val="C9D7D9"/>
+              </a:solidFill>
+              <a:ln w="9525" cap="flat">
+                <a:solidFill>
+                  <a:srgbClr val="C9D7D9"/>
+                </a:solidFill>
+                <a:prstDash val="solid"/>
+                <a:round/>
+              </a:ln>
+              <a:effectLst/>
+            </c:spPr>
+          </c:marker>
+          <c:cat>
+            <c:strRef>
+              <c:f>Sheet1!$A$2:$A$22</c:f>
+              <c:strCache>
+                <c:ptCount val="21"/>
+                <c:pt idx="0">
+                  <c:v>0</c:v>
+                </c:pt>
+                <c:pt idx="1">
+                  <c:v>1</c:v>
+                </c:pt>
+                <c:pt idx="2">
+                  <c:v>2</c:v>
+                </c:pt>
+                <c:pt idx="3">
+                  <c:v>3</c:v>
+                </c:pt>
+                <c:pt idx="4">
+                  <c:v>4</c:v>
+                </c:pt>
+                <c:pt idx="5">
+                  <c:v>5</c:v>
+                </c:pt>
+                <c:pt idx="6">
+                  <c:v>6</c:v>
+                </c:pt>
+                <c:pt idx="7">
+                  <c:v>7</c:v>
+                </c:pt>
+                <c:pt idx="8">
+                  <c:v>8</c:v>
+                </c:pt>
+                <c:pt idx="9">
+                  <c:v>9</c:v>
+                </c:pt>
+                <c:pt idx="10">
+                  <c:v>10</c:v>
+                </c:pt>
+                <c:pt idx="11">
+                  <c:v>11</c:v>
+                </c:pt>
+                <c:pt idx="12">
+                  <c:v>12</c:v>
+                </c:pt>
+                <c:pt idx="13">
+                  <c:v>13</c:v>
+                </c:pt>
+                <c:pt idx="14">
+                  <c:v>14</c:v>
+                </c:pt>
+                <c:pt idx="15">
+                  <c:v>15</c:v>
+                </c:pt>
+                <c:pt idx="16">
+                  <c:v>16</c:v>
+                </c:pt>
+                <c:pt idx="17">
+                  <c:v>17</c:v>
+                </c:pt>
+                <c:pt idx="18">
+                  <c:v>18</c:v>
+                </c:pt>
+                <c:pt idx="19">
+                  <c:v>19</c:v>
+                </c:pt>
+                <c:pt idx="20">
+                  <c:v>20</c:v>
+                </c:pt>
+              </c:strCache>
+            </c:strRef>
+          </c:cat>
+          <c:val>
+            <c:numRef>
+              <c:f>Sheet1!$B$2:$B$22</c:f>
+              <c:numCache>
+                <c:formatCode>General</c:formatCode>
+                <c:ptCount val="21"/>
+                <c:pt idx="0">
+                  <c:v>0.3901210165303764</c:v>
+                </c:pt>
+                <c:pt idx="1">
+                  <c:v>0.28639419088670715</c:v>
+                </c:pt>
+                <c:pt idx="2">
+                  <c:v>0.33929631721195591</c:v>
+                </c:pt>
+                <c:pt idx="3">
+                  <c:v>0.61778628849088513</c:v>
+                </c:pt>
+                <c:pt idx="4">
+                  <c:v>0.2734372854807588</c:v>
+                </c:pt>
+                <c:pt idx="5">
+                  <c:v>0.44100730431545865</c:v>
+                </c:pt>
+                <c:pt idx="6">
+                  <c:v>0.656774115775141</c:v>
+                </c:pt>
+                <c:pt idx="7">
+                  <c:v>0.26954600813078972</c:v>
+                </c:pt>
+                <c:pt idx="8">
+                  <c:v>0.30333270135025153</c:v>
+                </c:pt>
+                <c:pt idx="9">
+                  <c:v>0.74463176153117416</c:v>
+                </c:pt>
+                <c:pt idx="10">
+                  <c:v>0.44453101164872344</c:v>
+                </c:pt>
+                <c:pt idx="11">
+                  <c:v>0.48037238128267801</c:v>
+                </c:pt>
+                <c:pt idx="12">
+                  <c:v>0.66755042090897931</c:v>
+                </c:pt>
+                <c:pt idx="13">
+                  <c:v>0.74105048196672019</c:v>
+                </c:pt>
+                <c:pt idx="14">
+                  <c:v>0.5017758846756889</c:v>
+                </c:pt>
+                <c:pt idx="15">
+                  <c:v>0.68568855834225595</c:v>
+                </c:pt>
+                <c:pt idx="16">
+                  <c:v>0.64379562148535419</c:v>
+                </c:pt>
+                <c:pt idx="17">
+                  <c:v>0.59875611072581081</c:v>
+                </c:pt>
+                <c:pt idx="18">
+                  <c:v>0.78424924625281678</c:v>
+                </c:pt>
+                <c:pt idx="19">
+                  <c:v>0.99867972157601248</c:v>
+                </c:pt>
+                <c:pt idx="20">
+                  <c:v>0.81308101427884827</c:v>
+                </c:pt>
+              </c:numCache>
+            </c:numRef>
+          </c:val>
+          <c:smooth val="1"/>
+          <c:extLst>
+            <c:ext xmlns:c16="http://schemas.microsoft.com/office/drawing/2014/chart" uri="{C3380CC4-5D6E-409C-BE32-E72D297353CC}">
+              <c16:uniqueId val="{00000000-F716-374D-9151-8F7A3DB08765}"/>
+            </c:ext>
+          </c:extLst>
+        </c:ser>
+        <c:ser>
+          <c:idx val="1"/>
+          <c:order val="1"/>
+          <c:tx>
+            <c:strRef>
+              <c:f>Sheet1!$C$1</c:f>
+              <c:strCache>
+                <c:ptCount val="1"/>
+                <c:pt idx="0">
+                  <c:v>aggregated score (smooth)</c:v>
+                </c:pt>
+              </c:strCache>
+            </c:strRef>
+          </c:tx>
+          <c:spPr>
+            <a:ln w="25400" cap="flat">
+              <a:solidFill>
+                <a:srgbClr val="0E7C86"/>
+              </a:solidFill>
+              <a:prstDash val="solid"/>
+              <a:round/>
+            </a:ln>
+            <a:effectLst/>
+          </c:spPr>
+          <c:marker>
+            <c:symbol val="circle"/>
+            <c:size val="6"/>
+            <c:spPr>
+              <a:solidFill>
+                <a:srgbClr val="0E7C86"/>
+              </a:solidFill>
+              <a:ln w="9525" cap="flat">
+                <a:solidFill>
+                  <a:srgbClr val="0E7C86"/>
+                </a:solidFill>
+                <a:prstDash val="solid"/>
+                <a:round/>
+              </a:ln>
+              <a:effectLst/>
+            </c:spPr>
+          </c:marker>
+          <c:cat>
+            <c:strRef>
+              <c:f>Sheet1!$A$2:$A$22</c:f>
+              <c:strCache>
+                <c:ptCount val="21"/>
+                <c:pt idx="0">
+                  <c:v>0</c:v>
+                </c:pt>
+                <c:pt idx="1">
+                  <c:v>1</c:v>
+                </c:pt>
+                <c:pt idx="2">
+                  <c:v>2</c:v>
+                </c:pt>
+                <c:pt idx="3">
+                  <c:v>3</c:v>
+                </c:pt>
+                <c:pt idx="4">
+                  <c:v>4</c:v>
+                </c:pt>
+                <c:pt idx="5">
+                  <c:v>5</c:v>
+                </c:pt>
+                <c:pt idx="6">
+                  <c:v>6</c:v>
+                </c:pt>
+                <c:pt idx="7">
+                  <c:v>7</c:v>
+                </c:pt>
+                <c:pt idx="8">
+                  <c:v>8</c:v>
+                </c:pt>
+                <c:pt idx="9">
+                  <c:v>9</c:v>
+                </c:pt>
+                <c:pt idx="10">
+                  <c:v>10</c:v>
+                </c:pt>
+                <c:pt idx="11">
+                  <c:v>11</c:v>
+                </c:pt>
+                <c:pt idx="12">
+                  <c:v>12</c:v>
+                </c:pt>
+                <c:pt idx="13">
+                  <c:v>13</c:v>
+                </c:pt>
+                <c:pt idx="14">
+                  <c:v>14</c:v>
+                </c:pt>
+                <c:pt idx="15">
+                  <c:v>15</c:v>
+                </c:pt>
+                <c:pt idx="16">
+                  <c:v>16</c:v>
+                </c:pt>
+                <c:pt idx="17">
+                  <c:v>17</c:v>
+                </c:pt>
+                <c:pt idx="18">
+                  <c:v>18</c:v>
+                </c:pt>
+                <c:pt idx="19">
+                  <c:v>19</c:v>
+                </c:pt>
+                <c:pt idx="20">
+                  <c:v>20</c:v>
+                </c:pt>
+              </c:strCache>
+            </c:strRef>
+          </c:cat>
+          <c:val>
+            <c:numRef>
+              <c:f>Sheet1!$C$2:$C$22</c:f>
+              <c:numCache>
+                <c:formatCode>General</c:formatCode>
+                <c:ptCount val="21"/>
+                <c:pt idx="0">
+                  <c:v>0.3</c:v>
+                </c:pt>
+                <c:pt idx="1">
+                  <c:v>0.32500000000000001</c:v>
+                </c:pt>
+                <c:pt idx="2">
+                  <c:v>0.35</c:v>
+                </c:pt>
+                <c:pt idx="3">
+                  <c:v>0.375</c:v>
+                </c:pt>
+                <c:pt idx="4">
+                  <c:v>0.4</c:v>
+                </c:pt>
+                <c:pt idx="5">
+                  <c:v>0.42499999999999999</c:v>
+                </c:pt>
+                <c:pt idx="6">
+                  <c:v>0.44999999999999996</c:v>
+                </c:pt>
+                <c:pt idx="7">
+                  <c:v>0.47499999999999998</c:v>
+                </c:pt>
+                <c:pt idx="8">
+                  <c:v>0.5</c:v>
+                </c:pt>
+                <c:pt idx="9">
+                  <c:v>0.52500000000000002</c:v>
+                </c:pt>
+                <c:pt idx="10">
+                  <c:v>0.55000000000000004</c:v>
+                </c:pt>
+                <c:pt idx="11">
+                  <c:v>0.57499999999999996</c:v>
+                </c:pt>
+                <c:pt idx="12">
+                  <c:v>0.6</c:v>
+                </c:pt>
+                <c:pt idx="13">
+                  <c:v>0.625</c:v>
+                </c:pt>
+                <c:pt idx="14">
+                  <c:v>0.64999999999999991</c:v>
+                </c:pt>
+                <c:pt idx="15">
+                  <c:v>0.67500000000000004</c:v>
+                </c:pt>
+                <c:pt idx="16">
+                  <c:v>0.7</c:v>
+                </c:pt>
+                <c:pt idx="17">
+                  <c:v>0.72499999999999998</c:v>
+                </c:pt>
+                <c:pt idx="18">
+                  <c:v>0.75</c:v>
+                </c:pt>
+                <c:pt idx="19">
+                  <c:v>0.77499999999999991</c:v>
+                </c:pt>
+                <c:pt idx="20">
+                  <c:v>0.8</c:v>
+                </c:pt>
+              </c:numCache>
+            </c:numRef>
+          </c:val>
+          <c:smooth val="1"/>
+          <c:extLst>
+            <c:ext xmlns:c16="http://schemas.microsoft.com/office/drawing/2014/chart" uri="{C3380CC4-5D6E-409C-BE32-E72D297353CC}">
+              <c16:uniqueId val="{00000001-F716-374D-9151-8F7A3DB08765}"/>
+            </c:ext>
+          </c:extLst>
+        </c:ser>
+        <c:dLbls>
+          <c:showLegendKey val="0"/>
+          <c:showVal val="0"/>
+          <c:showCatName val="0"/>
+          <c:showSerName val="0"/>
+          <c:showPercent val="0"/>
+          <c:showBubbleSize val="0"/>
+        </c:dLbls>
+        <c:marker val="1"/>
+        <c:smooth val="0"/>
+        <c:axId val="2094734554"/>
+        <c:axId val="2094734552"/>
+      </c:lineChart>
+      <c:catAx>
+        <c:axId val="2094734554"/>
+        <c:scaling>
+          <c:orientation val="minMax"/>
+        </c:scaling>
+        <c:delete val="1"/>
+        <c:axPos val="b"/>
+        <c:numFmt formatCode="General" sourceLinked="1"/>
+        <c:majorTickMark val="out"/>
+        <c:minorTickMark val="none"/>
+        <c:tickLblPos val="low"/>
+        <c:crossAx val="2094734552"/>
+        <c:crosses val="autoZero"/>
+        <c:auto val="1"/>
+        <c:lblAlgn val="ctr"/>
+        <c:lblOffset val="100"/>
+        <c:noMultiLvlLbl val="1"/>
+      </c:catAx>
+      <c:valAx>
+        <c:axId val="2094734552"/>
+        <c:scaling>
+          <c:orientation val="minMax"/>
+          <c:max val="1"/>
+          <c:min val="0"/>
+        </c:scaling>
+        <c:delete val="0"/>
+        <c:axPos val="l"/>
+        <c:majorGridlines>
+          <c:spPr>
+            <a:ln w="6350" cap="flat">
+              <a:solidFill>
+                <a:srgbClr val="C9D7D9"/>
+              </a:solidFill>
+              <a:prstDash val="solid"/>
+              <a:round/>
+            </a:ln>
+          </c:spPr>
+        </c:majorGridlines>
+        <c:numFmt formatCode="General" sourceLinked="0"/>
+        <c:majorTickMark val="out"/>
+        <c:minorTickMark val="none"/>
+        <c:tickLblPos val="nextTo"/>
+        <c:spPr>
+          <a:ln w="12700" cap="flat">
+            <a:solidFill>
+              <a:srgbClr val="888888"/>
+            </a:solidFill>
+            <a:prstDash val="solid"/>
+            <a:round/>
+          </a:ln>
+        </c:spPr>
+        <c:txPr>
+          <a:bodyPr/>
+          <a:lstStyle/>
+          <a:p>
+            <a:pPr>
+              <a:defRPr sz="800" b="0" i="0" u="none" strike="noStrike">
+                <a:solidFill>
+                  <a:srgbClr val="5B6B70"/>
+                </a:solidFill>
+                <a:latin typeface="Arial"/>
+              </a:defRPr>
+            </a:pPr>
+            <a:endParaRPr lang="en-IT"/>
+          </a:p>
+        </c:txPr>
+        <c:crossAx val="2094734554"/>
+        <c:crosses val="autoZero"/>
+        <c:crossBetween val="between"/>
+      </c:valAx>
+      <c:spPr>
+        <a:noFill/>
+        <a:ln>
+          <a:noFill/>
+        </a:ln>
+        <a:effectLst/>
+      </c:spPr>
+    </c:plotArea>
+    <c:legend>
+      <c:legendPos val="b"/>
+      <c:overlay val="0"/>
+      <c:txPr>
+        <a:bodyPr/>
+        <a:lstStyle/>
+        <a:p>
+          <a:pPr>
+            <a:defRPr sz="900">
+              <a:solidFill>
+                <a:srgbClr val="5B6B70"/>
+              </a:solidFill>
+            </a:defRPr>
+          </a:pPr>
+          <a:endParaRPr lang="en-IT"/>
+        </a:p>
+      </c:txPr>
+    </c:legend>
+    <c:plotVisOnly val="1"/>
+    <c:dispBlanksAs val="span"/>
+    <c:showDLblsOverMax val="1"/>
+  </c:chart>
+  <c:spPr>
+    <a:noFill/>
+    <a:ln>
+      <a:noFill/>
+    </a:ln>
+    <a:effectLst/>
+  </c:spPr>
+  <c:externalData r:id="rId1">
+    <c:autoUpdate val="0"/>
+  </c:externalData>
+</c:chartSpace>
+</file>
+
 <file path=ppt/notesMasters/notesMaster1.xml><?xml version="1.0" encoding="utf-8"?>
 <p:notesMaster xmlns:a="http://schemas.openxmlformats.org/drawingml/2006/main" xmlns:r="http://schemas.openxmlformats.org/officeDocument/2006/relationships" xmlns:p="http://schemas.openxmlformats.org/presentationml/2006/main">
   <p:cSld>
@@ -1146,7 +1702,7 @@
           <a:p>
             <a:r>
               <a:rPr lang="en-US" dirty="0"/>
-              <a:t>1 min. The turn the course has been building toward. The most important lecture: in transcriptomics, representation of the biology is usually a bigger lever than the algorithm — and it's where biology training becomes a modelling superpower.</a:t>
+              <a:t>Feature extraction/ engineering -&gt; most important part</a:t>
             </a:r>
           </a:p>
         </p:txBody>
@@ -1233,7 +1789,7 @@
           <a:p>
             <a:r>
               <a:rPr lang="en-US" dirty="0"/>
-              <a:t>5 min. Keep genes that differ between outcomes — powerful, but SUPERVISED (uses the label) -&gt; leakage hazard. If done on all data it peeks at test outcomes. Rule: DE filtering inside the split, never before.</a:t>
+              <a:t>Second strategy -&gt; title -&gt; 1 -&gt; describe the volcano plot -&gt; 2 -&gt; 3 -&gt; 4 -&gt; 5 (trade off between low stringency (noisy) and high stringency (remove informative information)</a:t>
             </a:r>
           </a:p>
         </p:txBody>
@@ -1320,7 +1876,7 @@
           <a:p>
             <a:r>
               <a:rPr lang="en-US" dirty="0"/>
-              <a:t>4 min. Advantages: fewer features, faster, less overfitting, easier interpretation. Limitations: variance keeps noise; DE leaks &amp; is unstable. Filtering treats genes individually — ignores coordinated programmes. Motivates aggregation.</a:t>
+              <a:t>Title -&gt; left box -&gt; right box. Limitation is ignore coordinated program and biology works like this -&gt; few slides and we will see aggregation</a:t>
             </a:r>
           </a:p>
         </p:txBody>
@@ -1388,7 +1944,21 @@
             <p:ph type="sldImg"/>
           </p:nvPr>
         </p:nvSpPr>
-        <p:spPr/>
+        <p:spPr>
+          <a:xfrm>
+            <a:off x="-228600" y="1524000"/>
+            <a:ext cx="7315200" cy="4114800"/>
+          </a:xfrm>
+          <a:prstGeom prst="rect">
+            <a:avLst/>
+          </a:prstGeom>
+          <a:noFill/>
+          <a:ln w="12700">
+            <a:solidFill>
+              <a:prstClr val="black"/>
+            </a:solidFill>
+          </a:ln>
+        </p:spPr>
       </p:sp>
       <p:sp>
         <p:nvSpPr>
@@ -1400,45 +1970,66 @@
             <p:ph type="body" idx="1"/>
           </p:nvPr>
         </p:nvSpPr>
-        <p:spPr/>
+        <p:spPr>
+          <a:xfrm>
+            <a:off x="685800" y="5867400"/>
+            <a:ext cx="5486400" cy="4800600"/>
+          </a:xfrm>
+          <a:prstGeom prst="rect">
+            <a:avLst/>
+          </a:prstGeom>
+        </p:spPr>
         <p:txBody>
           <a:bodyPr/>
           <a:lstStyle/>
           <a:p>
             <a:r>
-              <a:rPr lang="en-US" dirty="0"/>
-              <a:t>5 min. Summarise coordinated gene programmes into a few scores. A signature score aggregates co-moving genes into one number. Benefits: less noise (averaging), prior knowledge, interpretable, stable. Biology becomes a modelling advantage.</a:t>
+              <a:rPr lang="en-IT" dirty="0"/>
+              <a:t>Next family of tools for feature selection. </a:t>
             </a:r>
-          </a:p>
-        </p:txBody>
-      </p:sp>
-      <p:sp>
-        <p:nvSpPr>
-          <p:cNvPr id="4" name="Slide Number Placeholder 3"/>
-          <p:cNvSpPr>
-            <a:spLocks noGrp="1"/>
-          </p:cNvSpPr>
-          <p:nvPr>
-            <p:ph type="sldNum" sz="quarter" idx="10"/>
-          </p:nvPr>
-        </p:nvSpPr>
-        <p:spPr/>
-        <p:txBody>
-          <a:bodyPr/>
-          <a:lstStyle/>
-          <a:p>
-            <a:fld id="{F7021451-1387-4CA6-816F-3879F97B5CBC}" type="slidenum">
-              <a:rPr lang="en-US"/>
-              <a:t>14</a:t>
-            </a:fld>
-            <a:endParaRPr lang="en-US"/>
+            <a:r>
+              <a:rPr lang="en-GB" dirty="0"/>
+              <a:t>I</a:t>
+            </a:r>
+            <a:r>
+              <a:rPr lang="en-IT" dirty="0"/>
+              <a:t>t’s a byproduct of models -&gt; tree based models, we will see them tomorrow. -&gt; random forest is a family of tree</a:t>
+            </a:r>
+            <a:r>
+              <a:rPr lang="en-IT" dirty="0">
+                <a:sym typeface="Wingdings" pitchFamily="2" charset="2"/>
+              </a:rPr>
+              <a:t> each branching occurs at a node. The purity measure how mixed is the population at a branching point -&gt; impurity score measures how much increase in purity after a branching point -&gt; importance in splitting patients into groups </a:t>
+            </a:r>
+          </a:p>
+          <a:p>
+            <a:endParaRPr lang="en-IT" dirty="0">
+              <a:sym typeface="Wingdings" pitchFamily="2" charset="2"/>
+            </a:endParaRPr>
+          </a:p>
+          <a:p>
+            <a:r>
+              <a:rPr lang="en-IT" dirty="0">
+                <a:sym typeface="Wingdings" pitchFamily="2" charset="2"/>
+              </a:rPr>
+              <a:t>Describe box on the left</a:t>
+            </a:r>
+          </a:p>
+          <a:p>
+            <a:r>
+              <a:rPr lang="en-IT" dirty="0">
+                <a:sym typeface="Wingdings" pitchFamily="2" charset="2"/>
+              </a:rPr>
+              <a:t>Alternative, which is model independent -&gt; SHAP value -&gt; box on the right</a:t>
+            </a:r>
+            <a:endParaRPr lang="en-IT" dirty="0"/>
           </a:p>
         </p:txBody>
       </p:sp>
     </p:spTree>
     <p:extLst>
       <p:ext uri="{BB962C8B-B14F-4D97-AF65-F5344CB8AC3E}">
-        <p14:creationId xmlns:p14="http://schemas.microsoft.com/office/powerpoint/2010/main" val="1024086991"/>
+        <p14:creationId xmlns:p14="http://schemas.microsoft.com/office/powerpoint/2010/main" val="3514437557"/>
       </p:ext>
     </p:extLst>
   </p:cSld>
@@ -1475,7 +2066,21 @@
             <p:ph type="sldImg"/>
           </p:nvPr>
         </p:nvSpPr>
-        <p:spPr/>
+        <p:spPr>
+          <a:xfrm>
+            <a:off x="-228600" y="1524000"/>
+            <a:ext cx="7315200" cy="4114800"/>
+          </a:xfrm>
+          <a:prstGeom prst="rect">
+            <a:avLst/>
+          </a:prstGeom>
+          <a:noFill/>
+          <a:ln w="12700">
+            <a:solidFill>
+              <a:prstClr val="black"/>
+            </a:solidFill>
+          </a:ln>
+        </p:spPr>
       </p:sp>
       <p:sp>
         <p:nvSpPr>
@@ -1487,45 +2092,30 @@
             <p:ph type="body" idx="1"/>
           </p:nvPr>
         </p:nvSpPr>
-        <p:spPr/>
+        <p:spPr>
+          <a:xfrm>
+            <a:off x="685800" y="5867400"/>
+            <a:ext cx="5486400" cy="4800600"/>
+          </a:xfrm>
+          <a:prstGeom prst="rect">
+            <a:avLst/>
+          </a:prstGeom>
+        </p:spPr>
         <p:txBody>
           <a:bodyPr/>
           <a:lstStyle/>
           <a:p>
             <a:r>
-              <a:rPr lang="en-US" dirty="0"/>
-              <a:t>5 min. Proliferation (cell-cycle) genes are among the strongest prognostic signals in HR+/HER2-. A proliferation score summarises aggressiveness — echoed by Ki-67 and commercial assays' proliferation modules. One robust score can beat hundreds of noisy genes.</a:t>
+              <a:rPr lang="en-IT" dirty="0"/>
+              <a:t>More advanced -&gt; sub title -&gt; question -&gt; how it works -&gt; left box </a:t>
             </a:r>
-          </a:p>
-        </p:txBody>
-      </p:sp>
-      <p:sp>
-        <p:nvSpPr>
-          <p:cNvPr id="4" name="Slide Number Placeholder 3"/>
-          <p:cNvSpPr>
-            <a:spLocks noGrp="1"/>
-          </p:cNvSpPr>
-          <p:nvPr>
-            <p:ph type="sldNum" sz="quarter" idx="10"/>
-          </p:nvPr>
-        </p:nvSpPr>
-        <p:spPr/>
-        <p:txBody>
-          <a:bodyPr/>
-          <a:lstStyle/>
-          <a:p>
-            <a:fld id="{F7021451-1387-4CA6-816F-3879F97B5CBC}" type="slidenum">
-              <a:rPr lang="en-US"/>
-              <a:t>15</a:t>
-            </a:fld>
-            <a:endParaRPr lang="en-US"/>
           </a:p>
         </p:txBody>
       </p:sp>
     </p:spTree>
     <p:extLst>
       <p:ext uri="{BB962C8B-B14F-4D97-AF65-F5344CB8AC3E}">
-        <p14:creationId xmlns:p14="http://schemas.microsoft.com/office/powerpoint/2010/main" val="1024086991"/>
+        <p14:creationId xmlns:p14="http://schemas.microsoft.com/office/powerpoint/2010/main" val="3430326721"/>
       </p:ext>
     </p:extLst>
   </p:cSld>
@@ -1581,7 +2171,15 @@
           <a:p>
             <a:r>
               <a:rPr lang="en-US" dirty="0"/>
-              <a:t>4 min. HR+ disease is defined by ER signalling. An ER-signalling score (ESR1, FOXA1, GATA3) captures luminal differentiation. Often protective: higher ER signalling -&gt; lower recurrence risk. Encodes the disease's defining biology in one feature.</a:t>
+              <a:t>Feature extraction -&gt; one gene by the time -&gt; limitation as biology does not work with 1 gene at the time -&gt; title -&gt; 1 -&gt; first panel figure -&gt; 3 (for less noisy, comment the plot) -&gt; 4 (with LLMs it’s easy to build a workflow, it’s much harder to build signatures that matter) -&gt; a generic ML engineer does not know that CCNB1 and MKI67 belong to the </a:t>
+            </a:r>
+            <a:r>
+              <a:rPr lang="en-US" dirty="0" err="1"/>
+              <a:t>profilieration</a:t>
+            </a:r>
+            <a:r>
+              <a:rPr lang="en-US" dirty="0"/>
+              <a:t> pathway, you do!</a:t>
             </a:r>
           </a:p>
         </p:txBody>
@@ -1603,7 +2201,7 @@
           <a:p>
             <a:fld id="{F7021451-1387-4CA6-816F-3879F97B5CBC}" type="slidenum">
               <a:rPr lang="en-US"/>
-              <a:t>16</a:t>
+              <a:t>14</a:t>
             </a:fld>
             <a:endParaRPr lang="en-US"/>
           </a:p>
@@ -1668,7 +2266,23 @@
           <a:p>
             <a:r>
               <a:rPr lang="en-US" dirty="0"/>
-              <a:t>5 min. Immune signatures capture anti-tumour immunity (often favourable); stromal capture the microenvironment (can mark progression). The tumour is an ecosystem; single genes miss it, programme scores capture it. Transferable across cancers.</a:t>
+              <a:t>In the context of HR+/HER2- there are several pathways that matter. One of these is the proliferation score -&gt; 1 -&gt; high proliferation = aggressiveness -&gt; 2 -&gt; to give you the importance of this score -&gt; 3 (KI67, oncotype, </a:t>
+            </a:r>
+            <a:r>
+              <a:rPr lang="en-US" dirty="0" err="1"/>
+              <a:t>mammaprint</a:t>
+            </a:r>
+            <a:r>
+              <a:rPr lang="en-US" dirty="0"/>
+              <a:t>) -&gt; 4 -&gt; in </a:t>
+            </a:r>
+            <a:r>
+              <a:rPr lang="en-US" dirty="0" err="1"/>
+              <a:t>metabric</a:t>
+            </a:r>
+            <a:r>
+              <a:rPr lang="en-US" dirty="0"/>
+              <a:t> I expect it to carry a lot of prediction power</a:t>
             </a:r>
           </a:p>
         </p:txBody>
@@ -1690,7 +2304,7 @@
           <a:p>
             <a:fld id="{F7021451-1387-4CA6-816F-3879F97B5CBC}" type="slidenum">
               <a:rPr lang="en-US"/>
-              <a:t>17</a:t>
+              <a:t>15</a:t>
             </a:fld>
             <a:endParaRPr lang="en-US"/>
           </a:p>
@@ -1755,7 +2369,23 @@
           <a:p>
             <a:r>
               <a:rPr lang="en-US" dirty="0"/>
-              <a:t>5 min. A gene set is a curated list sharing a function. MSigDB Hallmarks (~50 non-redundant), Reactome, GO, KEGG. Turn 20,000 genes into ~50-100 interpretable pathway activities — systematic biological feature engineering.</a:t>
+              <a:t>ER captures the defining biology -&gt; 1 -&gt; 2 -&gt; 3 (more differentiation -&gt; less aggressiveness) -&gt; we have two specific </a:t>
+            </a:r>
+            <a:r>
+              <a:rPr lang="en-US" dirty="0" err="1"/>
+              <a:t>signalling</a:t>
+            </a:r>
+            <a:r>
+              <a:rPr lang="en-US" dirty="0"/>
+              <a:t> you guys can use -&gt; question -&gt; binary vs continuum of HR </a:t>
+            </a:r>
+            <a:r>
+              <a:rPr lang="en-US" dirty="0" err="1"/>
+              <a:t>signalling</a:t>
+            </a:r>
+            <a:r>
+              <a:rPr lang="en-US" dirty="0"/>
+              <a:t> </a:t>
             </a:r>
           </a:p>
         </p:txBody>
@@ -1777,7 +2407,7 @@
           <a:p>
             <a:fld id="{F7021451-1387-4CA6-816F-3879F97B5CBC}" type="slidenum">
               <a:rPr lang="en-US"/>
-              <a:t>18</a:t>
+              <a:t>16</a:t>
             </a:fld>
             <a:endParaRPr lang="en-US"/>
           </a:p>
@@ -1842,7 +2472,23 @@
           <a:p>
             <a:r>
               <a:rPr lang="en-US" dirty="0"/>
-              <a:t>5 min. These methods score, per patient, how active each gene set is. We use them as a TOOL, not derive them. Output: patients x pathways matrix. 20,000 genes -&gt; ~50-100 features, ready for the same Logistic Regression.</a:t>
+              <a:t>Other signatures: 1 (depending on the type of immune infiltrate, but in general favorable) -&gt; 2 (high EMT -&gt; more aggressiveness) -&gt; 3 (ecosystem is made of </a:t>
+            </a:r>
+            <a:r>
+              <a:rPr lang="en-US" dirty="0" err="1"/>
+              <a:t>tumour</a:t>
+            </a:r>
+            <a:r>
+              <a:rPr lang="en-US" dirty="0"/>
+              <a:t> cells plus the </a:t>
+            </a:r>
+            <a:r>
+              <a:rPr lang="en-US" dirty="0" err="1"/>
+              <a:t>microenv</a:t>
+            </a:r>
+            <a:r>
+              <a:rPr lang="en-US" dirty="0"/>
+              <a:t> such as the immune cells, stromal) -&gt; 4 -&gt; 5 -&gt; deconvolution methods. Bulk is a mixture of cells. Given specific profiles of cell types</a:t>
             </a:r>
           </a:p>
         </p:txBody>
@@ -1864,7 +2510,7 @@
           <a:p>
             <a:fld id="{F7021451-1387-4CA6-816F-3879F97B5CBC}" type="slidenum">
               <a:rPr lang="en-US"/>
-              <a:t>19</a:t>
+              <a:t>17</a:t>
             </a:fld>
             <a:endParaRPr lang="en-US"/>
           </a:p>
@@ -1929,7 +2575,31 @@
           <a:p>
             <a:r>
               <a:rPr lang="en-US" dirty="0"/>
-              <a:t>4 min. Far fewer features -&gt; friendlier p:n. Each feature averages many genes -&gt; less noise, cross-cohort stability. Pathway activities are more comparable across platforms than raw probes (helps L1 batch). Interpretable axes.</a:t>
+              <a:t>Where do these pathways come from? Studies -&gt; researchers built </a:t>
+            </a:r>
+            <a:r>
+              <a:rPr lang="en-US" dirty="0" err="1"/>
+              <a:t>db</a:t>
+            </a:r>
+            <a:r>
+              <a:rPr lang="en-US" dirty="0"/>
+              <a:t> of these signatures called gene sets. This is the generalization of the pathways we saw. -&gt; 1 -&gt; 2 (</a:t>
+            </a:r>
+            <a:r>
+              <a:rPr lang="en-US" dirty="0" err="1"/>
+              <a:t>MSigDB</a:t>
+            </a:r>
+            <a:r>
+              <a:rPr lang="en-US" dirty="0"/>
+              <a:t> are no redundant) -&gt; 3  -&gt; 4 (feature engineering for most </a:t>
+            </a:r>
+            <a:r>
+              <a:rPr lang="en-US" dirty="0" err="1"/>
+              <a:t>ot</a:t>
+            </a:r>
+            <a:r>
+              <a:rPr lang="en-US" dirty="0"/>
+              <a:t> he most important processes, what we need) -&gt; right panels (the one we discussed are already present, comment them)</a:t>
             </a:r>
           </a:p>
         </p:txBody>
@@ -1951,7 +2621,7 @@
           <a:p>
             <a:fld id="{F7021451-1387-4CA6-816F-3879F97B5CBC}" type="slidenum">
               <a:rPr lang="en-US"/>
-              <a:t>20</a:t>
+              <a:t>18</a:t>
             </a:fld>
             <a:endParaRPr lang="en-US"/>
           </a:p>
@@ -2016,8 +2686,11 @@
           <a:p>
             <a:r>
               <a:rPr lang="en-US" dirty="0"/>
-              <a:t>5 min. Wrong: selection -&gt; CV (once, on everything). Right: CV -&gt; selection INSIDE each fold -&gt; train -&gt; evaluate. Applies to filtering, DE, signature fitting. Fixed published gene sets are largely exempt (no fitting on your labels).</a:t>
+              <a:t>Given the gene sets, or pathway features, how do we compute the scores or the activity? Here I present two methods: -&gt; Gene set variational analysis (for cohort) or single sample GSEA) -&gt; 1 -&gt; 2 -&gt; 3 -&gt; 4 -&gt; 5</a:t>
             </a:r>
+          </a:p>
+          <a:p>
+            <a:endParaRPr lang="en-US" dirty="0"/>
           </a:p>
         </p:txBody>
       </p:sp>
@@ -2038,7 +2711,7 @@
           <a:p>
             <a:fld id="{F7021451-1387-4CA6-816F-3879F97B5CBC}" type="slidenum">
               <a:rPr lang="en-US"/>
-              <a:t>21</a:t>
+              <a:t>19</a:t>
             </a:fld>
             <a:endParaRPr lang="en-US"/>
           </a:p>
@@ -2103,7 +2776,15 @@
           <a:p>
             <a:r>
               <a:rPr lang="en-US" dirty="0"/>
-              <a:t>2 min. L1 made problem &amp; data trustworthy; L2 gave a validated baseline by changing the MODEL. Today we freeze the model and change only the FEATURES — a controlled experiment. Representation is often the biggest lever on performance.</a:t>
+              <a:t>Small recap: 1 -&gt; 2 -&gt; 3 ((describe the model) -&gt; this is how you see the added value of something you </a:t>
+            </a:r>
+            <a:r>
+              <a:rPr lang="en-US" dirty="0" err="1"/>
+              <a:t>wanna</a:t>
+            </a:r>
+            <a:r>
+              <a:rPr lang="en-US" dirty="0"/>
+              <a:t> test -&gt; 4</a:t>
             </a:r>
           </a:p>
         </p:txBody>
@@ -2190,7 +2871,15 @@
           <a:p>
             <a:r>
               <a:rPr lang="en-US" dirty="0"/>
-              <a:t>5 min. Pathway models are far easier to interpret than gene-level. 'Risk rises with proliferation and falls with ER signalling' — a sentence a clinician trusts. Supports validation, hypotheses, adoption. Limit: depends on the gene set chosen.</a:t>
+              <a:t>To </a:t>
+            </a:r>
+            <a:r>
+              <a:rPr lang="en-US" dirty="0" err="1"/>
+              <a:t>summarise</a:t>
+            </a:r>
+            <a:r>
+              <a:rPr lang="en-US" dirty="0"/>
+              <a:t> -&gt; title -&gt; 1 -&gt;  2 (look at the plot) -&gt;  3 -&gt; 4 </a:t>
             </a:r>
           </a:p>
         </p:txBody>
@@ -2212,7 +2901,7 @@
           <a:p>
             <a:fld id="{F7021451-1387-4CA6-816F-3879F97B5CBC}" type="slidenum">
               <a:rPr lang="en-US"/>
-              <a:t>22</a:t>
+              <a:t>20</a:t>
             </a:fld>
             <a:endParaRPr lang="en-US"/>
           </a:p>
@@ -2277,7 +2966,7 @@
           <a:p>
             <a:r>
               <a:rPr lang="en-US" dirty="0"/>
-              <a:t>2 min. Deliver the thesis. Reorder instincts: representation and rigour first, algorithm last. The through-line: trustworthy problem (L1), trustworthy model (L2), trustworthy features (L3).</a:t>
+              <a:t>Again right and wrong workflow -&gt; up wrong -&gt; below right</a:t>
             </a:r>
           </a:p>
         </p:txBody>
@@ -2299,7 +2988,7 @@
           <a:p>
             <a:fld id="{F7021451-1387-4CA6-816F-3879F97B5CBC}" type="slidenum">
               <a:rPr lang="en-US"/>
-              <a:t>23</a:t>
+              <a:t>21</a:t>
             </a:fld>
             <a:endParaRPr lang="en-US"/>
           </a:p>
@@ -2364,8 +3053,191 @@
           <a:p>
             <a:r>
               <a:rPr lang="en-US" dirty="0"/>
-              <a:t>2 min. Tick objectives. Practical: five representations of the SAME data — all genes, variance-filtered, DE, signatures, pathways — same model; compare ROC-AUC, PR-AUC, feature count, stability, interpretability; diagnose a leaky workflow. Next: improving &amp; validating models.</a:t>
+              <a:t>Interpretation: pathway features makes interpretation easier -&gt; 2 -&gt; 3 (interpretation is </a:t>
             </a:r>
+            <a:r>
+              <a:rPr lang="en-US" dirty="0" err="1"/>
+              <a:t>crutial</a:t>
+            </a:r>
+            <a:r>
+              <a:rPr lang="en-US" dirty="0"/>
+              <a:t>, does it make sense biologically) -&gt; how do validate a finding -&gt; 4 -&gt; 5</a:t>
+            </a:r>
+          </a:p>
+        </p:txBody>
+      </p:sp>
+      <p:sp>
+        <p:nvSpPr>
+          <p:cNvPr id="4" name="Slide Number Placeholder 3"/>
+          <p:cNvSpPr>
+            <a:spLocks noGrp="1"/>
+          </p:cNvSpPr>
+          <p:nvPr>
+            <p:ph type="sldNum" sz="quarter" idx="10"/>
+          </p:nvPr>
+        </p:nvSpPr>
+        <p:spPr/>
+        <p:txBody>
+          <a:bodyPr/>
+          <a:lstStyle/>
+          <a:p>
+            <a:fld id="{F7021451-1387-4CA6-816F-3879F97B5CBC}" type="slidenum">
+              <a:rPr lang="en-US"/>
+              <a:t>22</a:t>
+            </a:fld>
+            <a:endParaRPr lang="en-US"/>
+          </a:p>
+        </p:txBody>
+      </p:sp>
+    </p:spTree>
+    <p:extLst>
+      <p:ext uri="{BB962C8B-B14F-4D97-AF65-F5344CB8AC3E}">
+        <p14:creationId xmlns:p14="http://schemas.microsoft.com/office/powerpoint/2010/main" val="1024086991"/>
+      </p:ext>
+    </p:extLst>
+  </p:cSld>
+  <p:clrMapOvr>
+    <a:masterClrMapping/>
+  </p:clrMapOvr>
+</p:notes>
+</file>
+
+<file path=ppt/notesSlides/notesSlide23.xml><?xml version="1.0" encoding="utf-8"?>
+<p:notes xmlns:a="http://schemas.openxmlformats.org/drawingml/2006/main" xmlns:r="http://schemas.openxmlformats.org/officeDocument/2006/relationships" xmlns:p="http://schemas.openxmlformats.org/presentationml/2006/main">
+  <p:cSld>
+    <p:spTree>
+      <p:nvGrpSpPr>
+        <p:cNvPr id="1" name=""/>
+        <p:cNvGrpSpPr/>
+        <p:nvPr/>
+      </p:nvGrpSpPr>
+      <p:grpSpPr>
+        <a:xfrm>
+          <a:off x="0" y="0"/>
+          <a:ext cx="0" cy="0"/>
+          <a:chOff x="0" y="0"/>
+          <a:chExt cx="0" cy="0"/>
+        </a:xfrm>
+      </p:grpSpPr>
+      <p:sp>
+        <p:nvSpPr>
+          <p:cNvPr id="2" name="Slide Image Placeholder 1"/>
+          <p:cNvSpPr>
+            <a:spLocks noGrp="1" noRot="1" noChangeAspect="1"/>
+          </p:cNvSpPr>
+          <p:nvPr>
+            <p:ph type="sldImg"/>
+          </p:nvPr>
+        </p:nvSpPr>
+        <p:spPr/>
+      </p:sp>
+      <p:sp>
+        <p:nvSpPr>
+          <p:cNvPr id="3" name="Notes Placeholder 2"/>
+          <p:cNvSpPr>
+            <a:spLocks noGrp="1"/>
+          </p:cNvSpPr>
+          <p:nvPr>
+            <p:ph type="body" idx="1"/>
+          </p:nvPr>
+        </p:nvSpPr>
+        <p:spPr/>
+        <p:txBody>
+          <a:bodyPr/>
+          <a:lstStyle/>
+          <a:p>
+            <a:r>
+              <a:rPr lang="en-US" dirty="0"/>
+              <a:t>Message specific for our field </a:t>
+            </a:r>
+          </a:p>
+        </p:txBody>
+      </p:sp>
+      <p:sp>
+        <p:nvSpPr>
+          <p:cNvPr id="4" name="Slide Number Placeholder 3"/>
+          <p:cNvSpPr>
+            <a:spLocks noGrp="1"/>
+          </p:cNvSpPr>
+          <p:nvPr>
+            <p:ph type="sldNum" sz="quarter" idx="10"/>
+          </p:nvPr>
+        </p:nvSpPr>
+        <p:spPr/>
+        <p:txBody>
+          <a:bodyPr/>
+          <a:lstStyle/>
+          <a:p>
+            <a:fld id="{F7021451-1387-4CA6-816F-3879F97B5CBC}" type="slidenum">
+              <a:rPr lang="en-US"/>
+              <a:t>23</a:t>
+            </a:fld>
+            <a:endParaRPr lang="en-US"/>
+          </a:p>
+        </p:txBody>
+      </p:sp>
+    </p:spTree>
+    <p:extLst>
+      <p:ext uri="{BB962C8B-B14F-4D97-AF65-F5344CB8AC3E}">
+        <p14:creationId xmlns:p14="http://schemas.microsoft.com/office/powerpoint/2010/main" val="1024086991"/>
+      </p:ext>
+    </p:extLst>
+  </p:cSld>
+  <p:clrMapOvr>
+    <a:masterClrMapping/>
+  </p:clrMapOvr>
+</p:notes>
+</file>
+
+<file path=ppt/notesSlides/notesSlide24.xml><?xml version="1.0" encoding="utf-8"?>
+<p:notes xmlns:a="http://schemas.openxmlformats.org/drawingml/2006/main" xmlns:r="http://schemas.openxmlformats.org/officeDocument/2006/relationships" xmlns:p="http://schemas.openxmlformats.org/presentationml/2006/main">
+  <p:cSld>
+    <p:spTree>
+      <p:nvGrpSpPr>
+        <p:cNvPr id="1" name=""/>
+        <p:cNvGrpSpPr/>
+        <p:nvPr/>
+      </p:nvGrpSpPr>
+      <p:grpSpPr>
+        <a:xfrm>
+          <a:off x="0" y="0"/>
+          <a:ext cx="0" cy="0"/>
+          <a:chOff x="0" y="0"/>
+          <a:chExt cx="0" cy="0"/>
+        </a:xfrm>
+      </p:grpSpPr>
+      <p:sp>
+        <p:nvSpPr>
+          <p:cNvPr id="2" name="Slide Image Placeholder 1"/>
+          <p:cNvSpPr>
+            <a:spLocks noGrp="1" noRot="1" noChangeAspect="1"/>
+          </p:cNvSpPr>
+          <p:nvPr>
+            <p:ph type="sldImg"/>
+          </p:nvPr>
+        </p:nvSpPr>
+        <p:spPr/>
+      </p:sp>
+      <p:sp>
+        <p:nvSpPr>
+          <p:cNvPr id="3" name="Notes Placeholder 2"/>
+          <p:cNvSpPr>
+            <a:spLocks noGrp="1"/>
+          </p:cNvSpPr>
+          <p:nvPr>
+            <p:ph type="body" idx="1"/>
+          </p:nvPr>
+        </p:nvSpPr>
+        <p:spPr/>
+        <p:txBody>
+          <a:bodyPr/>
+          <a:lstStyle/>
+          <a:p>
+            <a:r>
+              <a:rPr lang="en-US"/>
+              <a:t>recap</a:t>
+            </a:r>
+            <a:endParaRPr lang="en-US" dirty="0"/>
           </a:p>
         </p:txBody>
       </p:sp>
@@ -2451,7 +3323,7 @@
           <a:p>
             <a:r>
               <a:rPr lang="en-US" dirty="0"/>
-              <a:t>2 min. Checklist ticked as we go. The two that matter most: why biological aggregation helps, and recognising feature-selection leakage (subtler here — it hides in 'innocent' steps like DE filtering).</a:t>
+              <a:t>Describe all the objectives -&gt; most important are leakage again and biological features namely feature engineering</a:t>
             </a:r>
           </a:p>
         </p:txBody>
@@ -2538,7 +3410,7 @@
           <a:p>
             <a:r>
               <a:rPr lang="en-US" dirty="0"/>
-              <a:t>5 min. Garbage-in: a perfect algorithm on a poor representation still fails. 20k noisy genes carry huge noise per unit signal; 50 pathway scores far less. Features inject prior biology so the model needn't rediscover it from scarce data.</a:t>
+              <a:t>Title -&gt; 1 -&gt; change numbers -&gt; change representation -&gt; model performance changes -&gt; 2 -&gt; if we do not give the right info, even the best model won’t separate -&gt; biology described by 20k genes or 50 pathways (3) -&gt; 4 -&gt; 5 (this is also where your background comes in)</a:t>
             </a:r>
           </a:p>
         </p:txBody>
@@ -2625,8 +3497,13 @@
           <a:p>
             <a:r>
               <a:rPr lang="en-US" dirty="0"/>
-              <a:t>4 min. Same METABRIC patients, same Logistic Regression, different representations. A controlled experiment — only the representation changes. Hypothesis: fewer, biologically-coherent features generalise as well or better. Tested in the practical.</a:t>
+              <a:t>Example in the practice -&gt; 1 -&gt; 2 -&gt; 3 -&gt; 4 (yes and lots of patients) -&gt; figure </a:t>
             </a:r>
+            <a:r>
+              <a:rPr lang="en-US" dirty="0" err="1"/>
+              <a:t>coment</a:t>
+            </a:r>
+            <a:endParaRPr lang="en-US" dirty="0"/>
           </a:p>
         </p:txBody>
       </p:sp>
@@ -2712,7 +3589,7 @@
           <a:p>
             <a:r>
               <a:rPr lang="en-US" dirty="0"/>
-              <a:t>4 min. Each noisy feature is another chance to fit randomness. The model spreads finite attention across thousands of irrelevant genes. Aggregating to meaningful features concentrates signal and stabilises learning.</a:t>
+              <a:t>Title -&gt; 1 -&gt; 2 -&gt; 3 -&gt; 4 -&gt; figure (lost signal, but if you are able to combine them into single scores and isolate the one that might matter -&gt; this will stand out)</a:t>
             </a:r>
           </a:p>
         </p:txBody>
@@ -2799,7 +3676,7 @@
           <a:p>
             <a:r>
               <a:rPr lang="en-US" dirty="0"/>
-              <a:t>5 min. Engineering CREATES new features (genes -&gt; score). Selection CHOOSES a subset (keep 100 genes). Complementary, not rivals. Both are data-dependent decisions -&gt; both respect the split.</a:t>
+              <a:t>How do we reduce or build better features? Two jobs with two names -&gt; 1 (the model could learn it, but if you give it, you simplify models job) -&gt; 2 (you don’t create new things, just drop) -&gt;  3 -&gt; 4 -&gt; 5 -&gt; figure </a:t>
             </a:r>
           </a:p>
         </p:txBody>
@@ -2886,7 +3763,15 @@
           <a:p>
             <a:r>
               <a:rPr lang="en-US" dirty="0"/>
-              <a:t>5 min. Filter: rank independently of model (variance, correlation, DE). Embedded: selection during fitting (LASSO, Elastic Net). Tree-based: rank by usefulness for splitting. Choice depends on goal: speed, sparsity, stability, interpretability.</a:t>
+              <a:t>How do we do feature selection -&gt; 3 families we present here, there are more ways -&gt; panel left (no usage of label, outcome, limit data leakage) -&gt; central panel (model aware) -&gt; tree based -&gt; </a:t>
+            </a:r>
+            <a:r>
+              <a:rPr lang="en-US" dirty="0" err="1"/>
+              <a:t>botton</a:t>
+            </a:r>
+            <a:r>
+              <a:rPr lang="en-US" dirty="0"/>
+              <a:t> line</a:t>
             </a:r>
           </a:p>
         </p:txBody>
@@ -2973,7 +3858,7 @@
           <a:p>
             <a:r>
               <a:rPr lang="en-US" dirty="0"/>
-              <a:t>4 min. Drop genes that barely vary — they can't discriminate. Unsupervised (no labels) -&gt; low leakage risk, safe first pass. But high variance != biological relevance; a noisy probe can be high-variance.</a:t>
+              <a:t>Title -&gt; simplest -&gt; 1 ( the ones that do not vary should not help, unless they are all consistently small changing, low chance) -&gt; 2 -&gt; 3 -&gt; 4. You do it by plotting variance histogram or just removing low percentile</a:t>
             </a:r>
           </a:p>
         </p:txBody>
@@ -16665,6 +17550,45 @@
               </a:rPr>
               <a:t>These signatures are reused across cancer types, transferable biological features.</a:t>
             </a:r>
+          </a:p>
+          <a:p>
+            <a:pPr marL="203200" indent="-203200">
+              <a:spcAft>
+                <a:spcPts val="1200"/>
+              </a:spcAft>
+              <a:buSzPct val="100000"/>
+              <a:buChar char="•"/>
+            </a:pPr>
+            <a:r>
+              <a:rPr lang="en-US" sz="1500" b="1" dirty="0">
+                <a:solidFill>
+                  <a:srgbClr val="0E7C86"/>
+                </a:solidFill>
+                <a:latin typeface="Calibri" pitchFamily="34" charset="0"/>
+                <a:cs typeface="Calibri" pitchFamily="34" charset="-120"/>
+              </a:rPr>
+              <a:t>How do you extract immune score from bulk </a:t>
+            </a:r>
+            <a:r>
+              <a:rPr lang="en-US" sz="1500" b="1" dirty="0" err="1">
+                <a:solidFill>
+                  <a:srgbClr val="0E7C86"/>
+                </a:solidFill>
+                <a:latin typeface="Calibri" pitchFamily="34" charset="0"/>
+                <a:cs typeface="Calibri" pitchFamily="34" charset="-120"/>
+              </a:rPr>
+              <a:t>RNAseq</a:t>
+            </a:r>
+            <a:r>
+              <a:rPr lang="en-US" sz="1500" b="1" dirty="0">
+                <a:solidFill>
+                  <a:srgbClr val="0E7C86"/>
+                </a:solidFill>
+                <a:latin typeface="Calibri" pitchFamily="34" charset="0"/>
+                <a:cs typeface="Calibri" pitchFamily="34" charset="-120"/>
+              </a:rPr>
+              <a:t>?</a:t>
+            </a:r>
             <a:endParaRPr lang="en-US" sz="1500" dirty="0"/>
           </a:p>
         </p:txBody>
@@ -18498,6 +19422,17 @@
               <a:buChar char="•"/>
             </a:pPr>
             <a:r>
+              <a:rPr lang="en-US" sz="1500" dirty="0" err="1">
+                <a:solidFill>
+                  <a:srgbClr val="12262B"/>
+                </a:solidFill>
+                <a:latin typeface="Calibri" pitchFamily="34" charset="0"/>
+                <a:ea typeface="Calibri" pitchFamily="34" charset="-122"/>
+                <a:cs typeface="Calibri" pitchFamily="34" charset="-120"/>
+              </a:rPr>
+              <a:t>ssGSEA</a:t>
+            </a:r>
+            <a:r>
               <a:rPr lang="en-US" sz="1500" dirty="0">
                 <a:solidFill>
                   <a:srgbClr val="12262B"/>
@@ -18506,7 +19441,26 @@
                 <a:ea typeface="Calibri" pitchFamily="34" charset="-122"/>
                 <a:cs typeface="Calibri" pitchFamily="34" charset="-120"/>
               </a:rPr>
-              <a:t>Scoring is per-sample: each score stands alone, independent of the rest of the cohort.</a:t>
+              <a:t>: Scoring is per-sample: each score stands alone, independent of the rest of the cohort.</a:t>
+            </a:r>
+          </a:p>
+          <a:p>
+            <a:pPr marL="203200" indent="-203200">
+              <a:spcAft>
+                <a:spcPts val="900"/>
+              </a:spcAft>
+              <a:buSzPct val="100000"/>
+              <a:buChar char="•"/>
+            </a:pPr>
+            <a:r>
+              <a:rPr lang="en-US" sz="1500" dirty="0">
+                <a:solidFill>
+                  <a:srgbClr val="12262B"/>
+                </a:solidFill>
+                <a:latin typeface="Calibri" pitchFamily="34" charset="0"/>
+                <a:cs typeface="Calibri" pitchFamily="34" charset="-120"/>
+              </a:rPr>
+              <a:t>GSVA: build statistics from whole cohort (mind the splits!) -&gt; build a patient specific score</a:t>
             </a:r>
             <a:endParaRPr lang="en-US" sz="1500" dirty="0"/>
           </a:p>
@@ -18527,7 +19481,7 @@
                 <a:ea typeface="Calibri" pitchFamily="34" charset="-122"/>
                 <a:cs typeface="Calibri" pitchFamily="34" charset="-120"/>
               </a:rPr>
-              <a:t>Result: 20,000 genes → ~50–100 pathway features, ready for the same Logistic Regression.</a:t>
+              <a:t>Result: 20,000 genes → ~50-100 pathway features, ready for the same Logistic Regression.</a:t>
             </a:r>
             <a:endParaRPr lang="en-US" sz="1500" dirty="0"/>
           </a:p>
@@ -24236,6 +25190,34 @@
           </a:p>
         </p:txBody>
       </p:sp>
+      <p:graphicFrame>
+        <p:nvGraphicFramePr>
+          <p:cNvPr id="6" name="Chart 0">
+            <a:extLst>
+              <a:ext uri="{FF2B5EF4-FFF2-40B4-BE49-F238E27FC236}">
+                <a16:creationId xmlns:a16="http://schemas.microsoft.com/office/drawing/2014/main" id="{6FA95EC6-94D1-9385-D455-A04D3C3BB1C2}"/>
+              </a:ext>
+            </a:extLst>
+          </p:cNvPr>
+          <p:cNvGraphicFramePr/>
+          <p:nvPr>
+            <p:extLst>
+              <p:ext uri="{D42A27DB-BD31-4B8C-83A1-F6EECF244321}">
+                <p14:modId xmlns:p14="http://schemas.microsoft.com/office/powerpoint/2010/main" val="3548646984"/>
+              </p:ext>
+            </p:extLst>
+          </p:nvPr>
+        </p:nvGraphicFramePr>
+        <p:xfrm>
+          <a:off x="6892834" y="2148840"/>
+          <a:ext cx="5120640" cy="2743200"/>
+        </p:xfrm>
+        <a:graphic>
+          <a:graphicData uri="http://schemas.openxmlformats.org/drawingml/2006/chart">
+            <c:chart xmlns:c="http://schemas.openxmlformats.org/drawingml/2006/chart" xmlns:r="http://schemas.openxmlformats.org/officeDocument/2006/relationships" r:id="rId3"/>
+          </a:graphicData>
+        </a:graphic>
+      </p:graphicFrame>
     </p:spTree>
   </p:cSld>
   <p:clrMapOvr>
@@ -39185,7 +40167,7 @@
                 <a:ea typeface="Calibri" pitchFamily="34" charset="-122"/>
                 <a:cs typeface="Calibri" pitchFamily="34" charset="-120"/>
               </a:rPr>
-              <a:t>Choice depends on goals: speed · sparsity · stability · interpretability</a:t>
+              <a:t>Choice depends on goals: speed · stability · interpretability</a:t>
             </a:r>
             <a:endParaRPr lang="en-US" sz="1300" dirty="0"/>
           </a:p>
@@ -39417,7 +40399,7 @@
                 <a:ea typeface="Calibri" pitchFamily="34" charset="-122"/>
                 <a:cs typeface="Calibri" pitchFamily="34" charset="-120"/>
               </a:rPr>
-              <a:t>Drop genes that barely vary across patients — they cannot help discriminate.</a:t>
+              <a:t>Drop genes that barely vary across patients: they cannot help discriminate.</a:t>
             </a:r>
             <a:endParaRPr lang="en-US" sz="1550" dirty="0"/>
           </a:p>

</xml_diff>